<commit_message>
slides: fix XML that Google Slides rejects
Table cells wrote their fill before their borders, and the approach diagram
wrote fractional coordinates. PowerPoint and LibreOffice tolerate both;
Google Slides refused to open the file. Every slide, notes page and the
chart now pass the OOXML schema.
</commit_message>
<xml_diff>
--- a/slides/DEM_advisor_deck.pptx
+++ b/slides/DEM_advisor_deck.pptx
@@ -11988,9 +11988,6 @@
                     </a:p>
                   </a:txBody>
                   <a:tcPr marL="54864" marR="54864" marT="18288" marB="18288" anchor="ctr">
-                    <a:solidFill>
-                      <a:srgbClr val="57068C"/>
-                    </a:solidFill>
                     <a:lnL w="0">
                       <a:noFill/>
                     </a:lnL>
@@ -12005,6 +12002,9 @@
                         <a:srgbClr val="D9D3E3"/>
                       </a:solidFill>
                     </a:lnB>
+                    <a:solidFill>
+                      <a:srgbClr val="57068C"/>
+                    </a:solidFill>
                   </a:tcPr>
                 </a:tc>
                 <a:tc>
@@ -12024,9 +12024,6 @@
                     </a:p>
                   </a:txBody>
                   <a:tcPr marL="54864" marR="54864" marT="18288" marB="18288" anchor="ctr">
-                    <a:solidFill>
-                      <a:srgbClr val="57068C"/>
-                    </a:solidFill>
                     <a:lnL w="0">
                       <a:noFill/>
                     </a:lnL>
@@ -12041,6 +12038,9 @@
                         <a:srgbClr val="D9D3E3"/>
                       </a:solidFill>
                     </a:lnB>
+                    <a:solidFill>
+                      <a:srgbClr val="57068C"/>
+                    </a:solidFill>
                   </a:tcPr>
                 </a:tc>
                 <a:tc>
@@ -12060,9 +12060,6 @@
                     </a:p>
                   </a:txBody>
                   <a:tcPr marL="54864" marR="54864" marT="18288" marB="18288" anchor="ctr">
-                    <a:solidFill>
-                      <a:srgbClr val="57068C"/>
-                    </a:solidFill>
                     <a:lnL w="0">
                       <a:noFill/>
                     </a:lnL>
@@ -12077,6 +12074,9 @@
                         <a:srgbClr val="D9D3E3"/>
                       </a:solidFill>
                     </a:lnB>
+                    <a:solidFill>
+                      <a:srgbClr val="57068C"/>
+                    </a:solidFill>
                   </a:tcPr>
                 </a:tc>
                 <a:tc>
@@ -12096,9 +12096,6 @@
                     </a:p>
                   </a:txBody>
                   <a:tcPr marL="54864" marR="54864" marT="18288" marB="18288" anchor="ctr">
-                    <a:solidFill>
-                      <a:srgbClr val="57068C"/>
-                    </a:solidFill>
                     <a:lnL w="0">
                       <a:noFill/>
                     </a:lnL>
@@ -12113,6 +12110,9 @@
                         <a:srgbClr val="D9D3E3"/>
                       </a:solidFill>
                     </a:lnB>
+                    <a:solidFill>
+                      <a:srgbClr val="57068C"/>
+                    </a:solidFill>
                   </a:tcPr>
                 </a:tc>
                 <a:tc>
@@ -12132,9 +12132,6 @@
                     </a:p>
                   </a:txBody>
                   <a:tcPr marL="54864" marR="54864" marT="18288" marB="18288" anchor="ctr">
-                    <a:solidFill>
-                      <a:srgbClr val="57068C"/>
-                    </a:solidFill>
                     <a:lnL w="0">
                       <a:noFill/>
                     </a:lnL>
@@ -12149,6 +12146,9 @@
                         <a:srgbClr val="D9D3E3"/>
                       </a:solidFill>
                     </a:lnB>
+                    <a:solidFill>
+                      <a:srgbClr val="57068C"/>
+                    </a:solidFill>
                   </a:tcPr>
                 </a:tc>
                 <a:tc>
@@ -12168,9 +12168,6 @@
                     </a:p>
                   </a:txBody>
                   <a:tcPr marL="54864" marR="54864" marT="18288" marB="18288" anchor="ctr">
-                    <a:solidFill>
-                      <a:srgbClr val="57068C"/>
-                    </a:solidFill>
                     <a:lnL w="0">
                       <a:noFill/>
                     </a:lnL>
@@ -12185,6 +12182,9 @@
                         <a:srgbClr val="D9D3E3"/>
                       </a:solidFill>
                     </a:lnB>
+                    <a:solidFill>
+                      <a:srgbClr val="57068C"/>
+                    </a:solidFill>
                   </a:tcPr>
                 </a:tc>
                 <a:tc>
@@ -12204,9 +12204,6 @@
                     </a:p>
                   </a:txBody>
                   <a:tcPr marL="54864" marR="54864" marT="18288" marB="18288" anchor="ctr">
-                    <a:solidFill>
-                      <a:srgbClr val="57068C"/>
-                    </a:solidFill>
                     <a:lnL w="0">
                       <a:noFill/>
                     </a:lnL>
@@ -12221,6 +12218,9 @@
                         <a:srgbClr val="D9D3E3"/>
                       </a:solidFill>
                     </a:lnB>
+                    <a:solidFill>
+                      <a:srgbClr val="57068C"/>
+                    </a:solidFill>
                   </a:tcPr>
                 </a:tc>
               </a:tr>
@@ -12242,9 +12242,6 @@
                     </a:p>
                   </a:txBody>
                   <a:tcPr marL="54864" marR="54864" marT="18288" marB="18288" anchor="ctr">
-                    <a:solidFill>
-                      <a:srgbClr val="FFFFFF"/>
-                    </a:solidFill>
                     <a:lnL w="0">
                       <a:noFill/>
                     </a:lnL>
@@ -12259,6 +12256,9 @@
                         <a:srgbClr val="D9D3E3"/>
                       </a:solidFill>
                     </a:lnB>
+                    <a:solidFill>
+                      <a:srgbClr val="FFFFFF"/>
+                    </a:solidFill>
                   </a:tcPr>
                 </a:tc>
                 <a:tc>
@@ -12278,9 +12278,6 @@
                     </a:p>
                   </a:txBody>
                   <a:tcPr marL="54864" marR="54864" marT="18288" marB="18288" anchor="ctr">
-                    <a:solidFill>
-                      <a:srgbClr val="FFFFFF"/>
-                    </a:solidFill>
                     <a:lnL w="0">
                       <a:noFill/>
                     </a:lnL>
@@ -12295,6 +12292,9 @@
                         <a:srgbClr val="D9D3E3"/>
                       </a:solidFill>
                     </a:lnB>
+                    <a:solidFill>
+                      <a:srgbClr val="FFFFFF"/>
+                    </a:solidFill>
                   </a:tcPr>
                 </a:tc>
                 <a:tc>
@@ -12314,9 +12314,6 @@
                     </a:p>
                   </a:txBody>
                   <a:tcPr marL="54864" marR="54864" marT="18288" marB="18288" anchor="ctr">
-                    <a:solidFill>
-                      <a:srgbClr val="FFFFFF"/>
-                    </a:solidFill>
                     <a:lnL w="0">
                       <a:noFill/>
                     </a:lnL>
@@ -12331,6 +12328,9 @@
                         <a:srgbClr val="D9D3E3"/>
                       </a:solidFill>
                     </a:lnB>
+                    <a:solidFill>
+                      <a:srgbClr val="FFFFFF"/>
+                    </a:solidFill>
                   </a:tcPr>
                 </a:tc>
                 <a:tc>
@@ -12350,9 +12350,6 @@
                     </a:p>
                   </a:txBody>
                   <a:tcPr marL="54864" marR="54864" marT="18288" marB="18288" anchor="ctr">
-                    <a:solidFill>
-                      <a:srgbClr val="FFFFFF"/>
-                    </a:solidFill>
                     <a:lnL w="0">
                       <a:noFill/>
                     </a:lnL>
@@ -12367,6 +12364,9 @@
                         <a:srgbClr val="D9D3E3"/>
                       </a:solidFill>
                     </a:lnB>
+                    <a:solidFill>
+                      <a:srgbClr val="FFFFFF"/>
+                    </a:solidFill>
                   </a:tcPr>
                 </a:tc>
                 <a:tc>
@@ -12386,9 +12386,6 @@
                     </a:p>
                   </a:txBody>
                   <a:tcPr marL="54864" marR="54864" marT="18288" marB="18288" anchor="ctr">
-                    <a:solidFill>
-                      <a:srgbClr val="FFFFFF"/>
-                    </a:solidFill>
                     <a:lnL w="0">
                       <a:noFill/>
                     </a:lnL>
@@ -12403,6 +12400,9 @@
                         <a:srgbClr val="D9D3E3"/>
                       </a:solidFill>
                     </a:lnB>
+                    <a:solidFill>
+                      <a:srgbClr val="FFFFFF"/>
+                    </a:solidFill>
                   </a:tcPr>
                 </a:tc>
                 <a:tc>
@@ -12422,9 +12422,6 @@
                     </a:p>
                   </a:txBody>
                   <a:tcPr marL="54864" marR="54864" marT="18288" marB="18288" anchor="ctr">
-                    <a:solidFill>
-                      <a:srgbClr val="FFFFFF"/>
-                    </a:solidFill>
                     <a:lnL w="0">
                       <a:noFill/>
                     </a:lnL>
@@ -12439,6 +12436,9 @@
                         <a:srgbClr val="D9D3E3"/>
                       </a:solidFill>
                     </a:lnB>
+                    <a:solidFill>
+                      <a:srgbClr val="FFFFFF"/>
+                    </a:solidFill>
                   </a:tcPr>
                 </a:tc>
                 <a:tc>
@@ -12458,9 +12458,6 @@
                     </a:p>
                   </a:txBody>
                   <a:tcPr marL="54864" marR="54864" marT="18288" marB="18288" anchor="ctr">
-                    <a:solidFill>
-                      <a:srgbClr val="FFFFFF"/>
-                    </a:solidFill>
                     <a:lnL w="0">
                       <a:noFill/>
                     </a:lnL>
@@ -12475,6 +12472,9 @@
                         <a:srgbClr val="D9D3E3"/>
                       </a:solidFill>
                     </a:lnB>
+                    <a:solidFill>
+                      <a:srgbClr val="FFFFFF"/>
+                    </a:solidFill>
                   </a:tcPr>
                 </a:tc>
               </a:tr>
@@ -12496,9 +12496,6 @@
                     </a:p>
                   </a:txBody>
                   <a:tcPr marL="54864" marR="54864" marT="18288" marB="18288" anchor="ctr">
-                    <a:solidFill>
-                      <a:srgbClr val="E3DFE9"/>
-                    </a:solidFill>
                     <a:lnL w="0">
                       <a:noFill/>
                     </a:lnL>
@@ -12513,6 +12510,9 @@
                         <a:srgbClr val="D9D3E3"/>
                       </a:solidFill>
                     </a:lnB>
+                    <a:solidFill>
+                      <a:srgbClr val="E3DFE9"/>
+                    </a:solidFill>
                   </a:tcPr>
                 </a:tc>
                 <a:tc>
@@ -12532,9 +12532,6 @@
                     </a:p>
                   </a:txBody>
                   <a:tcPr marL="54864" marR="54864" marT="18288" marB="18288" anchor="ctr">
-                    <a:solidFill>
-                      <a:srgbClr val="E3DFE9"/>
-                    </a:solidFill>
                     <a:lnL w="0">
                       <a:noFill/>
                     </a:lnL>
@@ -12549,6 +12546,9 @@
                         <a:srgbClr val="D9D3E3"/>
                       </a:solidFill>
                     </a:lnB>
+                    <a:solidFill>
+                      <a:srgbClr val="E3DFE9"/>
+                    </a:solidFill>
                   </a:tcPr>
                 </a:tc>
                 <a:tc>
@@ -12568,9 +12568,6 @@
                     </a:p>
                   </a:txBody>
                   <a:tcPr marL="54864" marR="54864" marT="18288" marB="18288" anchor="ctr">
-                    <a:solidFill>
-                      <a:srgbClr val="E3DFE9"/>
-                    </a:solidFill>
                     <a:lnL w="0">
                       <a:noFill/>
                     </a:lnL>
@@ -12585,6 +12582,9 @@
                         <a:srgbClr val="D9D3E3"/>
                       </a:solidFill>
                     </a:lnB>
+                    <a:solidFill>
+                      <a:srgbClr val="E3DFE9"/>
+                    </a:solidFill>
                   </a:tcPr>
                 </a:tc>
                 <a:tc>
@@ -12604,9 +12604,6 @@
                     </a:p>
                   </a:txBody>
                   <a:tcPr marL="54864" marR="54864" marT="18288" marB="18288" anchor="ctr">
-                    <a:solidFill>
-                      <a:srgbClr val="E3DFE9"/>
-                    </a:solidFill>
                     <a:lnL w="0">
                       <a:noFill/>
                     </a:lnL>
@@ -12621,6 +12618,9 @@
                         <a:srgbClr val="D9D3E3"/>
                       </a:solidFill>
                     </a:lnB>
+                    <a:solidFill>
+                      <a:srgbClr val="E3DFE9"/>
+                    </a:solidFill>
                   </a:tcPr>
                 </a:tc>
                 <a:tc>
@@ -12640,9 +12640,6 @@
                     </a:p>
                   </a:txBody>
                   <a:tcPr marL="54864" marR="54864" marT="18288" marB="18288" anchor="ctr">
-                    <a:solidFill>
-                      <a:srgbClr val="E3DFE9"/>
-                    </a:solidFill>
                     <a:lnL w="0">
                       <a:noFill/>
                     </a:lnL>
@@ -12657,6 +12654,9 @@
                         <a:srgbClr val="D9D3E3"/>
                       </a:solidFill>
                     </a:lnB>
+                    <a:solidFill>
+                      <a:srgbClr val="E3DFE9"/>
+                    </a:solidFill>
                   </a:tcPr>
                 </a:tc>
                 <a:tc>
@@ -12676,9 +12676,6 @@
                     </a:p>
                   </a:txBody>
                   <a:tcPr marL="54864" marR="54864" marT="18288" marB="18288" anchor="ctr">
-                    <a:solidFill>
-                      <a:srgbClr val="E3DFE9"/>
-                    </a:solidFill>
                     <a:lnL w="0">
                       <a:noFill/>
                     </a:lnL>
@@ -12693,6 +12690,9 @@
                         <a:srgbClr val="D9D3E3"/>
                       </a:solidFill>
                     </a:lnB>
+                    <a:solidFill>
+                      <a:srgbClr val="E3DFE9"/>
+                    </a:solidFill>
                   </a:tcPr>
                 </a:tc>
                 <a:tc>
@@ -12712,9 +12712,6 @@
                     </a:p>
                   </a:txBody>
                   <a:tcPr marL="54864" marR="54864" marT="18288" marB="18288" anchor="ctr">
-                    <a:solidFill>
-                      <a:srgbClr val="E3DFE9"/>
-                    </a:solidFill>
                     <a:lnL w="0">
                       <a:noFill/>
                     </a:lnL>
@@ -12729,6 +12726,9 @@
                         <a:srgbClr val="D9D3E3"/>
                       </a:solidFill>
                     </a:lnB>
+                    <a:solidFill>
+                      <a:srgbClr val="E3DFE9"/>
+                    </a:solidFill>
                   </a:tcPr>
                 </a:tc>
               </a:tr>
@@ -12750,9 +12750,6 @@
                     </a:p>
                   </a:txBody>
                   <a:tcPr marL="54864" marR="54864" marT="18288" marB="18288" anchor="ctr">
-                    <a:solidFill>
-                      <a:srgbClr val="FFFFFF"/>
-                    </a:solidFill>
                     <a:lnL w="0">
                       <a:noFill/>
                     </a:lnL>
@@ -12767,6 +12764,9 @@
                         <a:srgbClr val="D9D3E3"/>
                       </a:solidFill>
                     </a:lnB>
+                    <a:solidFill>
+                      <a:srgbClr val="FFFFFF"/>
+                    </a:solidFill>
                   </a:tcPr>
                 </a:tc>
                 <a:tc>
@@ -12786,9 +12786,6 @@
                     </a:p>
                   </a:txBody>
                   <a:tcPr marL="54864" marR="54864" marT="18288" marB="18288" anchor="ctr">
-                    <a:solidFill>
-                      <a:srgbClr val="FFFFFF"/>
-                    </a:solidFill>
                     <a:lnL w="0">
                       <a:noFill/>
                     </a:lnL>
@@ -12803,6 +12800,9 @@
                         <a:srgbClr val="D9D3E3"/>
                       </a:solidFill>
                     </a:lnB>
+                    <a:solidFill>
+                      <a:srgbClr val="FFFFFF"/>
+                    </a:solidFill>
                   </a:tcPr>
                 </a:tc>
                 <a:tc>
@@ -12822,9 +12822,6 @@
                     </a:p>
                   </a:txBody>
                   <a:tcPr marL="54864" marR="54864" marT="18288" marB="18288" anchor="ctr">
-                    <a:solidFill>
-                      <a:srgbClr val="FFFFFF"/>
-                    </a:solidFill>
                     <a:lnL w="0">
                       <a:noFill/>
                     </a:lnL>
@@ -12839,6 +12836,9 @@
                         <a:srgbClr val="D9D3E3"/>
                       </a:solidFill>
                     </a:lnB>
+                    <a:solidFill>
+                      <a:srgbClr val="FFFFFF"/>
+                    </a:solidFill>
                   </a:tcPr>
                 </a:tc>
                 <a:tc>
@@ -12858,9 +12858,6 @@
                     </a:p>
                   </a:txBody>
                   <a:tcPr marL="54864" marR="54864" marT="18288" marB="18288" anchor="ctr">
-                    <a:solidFill>
-                      <a:srgbClr val="FFFFFF"/>
-                    </a:solidFill>
                     <a:lnL w="0">
                       <a:noFill/>
                     </a:lnL>
@@ -12875,6 +12872,9 @@
                         <a:srgbClr val="D9D3E3"/>
                       </a:solidFill>
                     </a:lnB>
+                    <a:solidFill>
+                      <a:srgbClr val="FFFFFF"/>
+                    </a:solidFill>
                   </a:tcPr>
                 </a:tc>
                 <a:tc>
@@ -12894,9 +12894,6 @@
                     </a:p>
                   </a:txBody>
                   <a:tcPr marL="54864" marR="54864" marT="18288" marB="18288" anchor="ctr">
-                    <a:solidFill>
-                      <a:srgbClr val="FFFFFF"/>
-                    </a:solidFill>
                     <a:lnL w="0">
                       <a:noFill/>
                     </a:lnL>
@@ -12911,6 +12908,9 @@
                         <a:srgbClr val="D9D3E3"/>
                       </a:solidFill>
                     </a:lnB>
+                    <a:solidFill>
+                      <a:srgbClr val="FFFFFF"/>
+                    </a:solidFill>
                   </a:tcPr>
                 </a:tc>
                 <a:tc>
@@ -12930,9 +12930,6 @@
                     </a:p>
                   </a:txBody>
                   <a:tcPr marL="54864" marR="54864" marT="18288" marB="18288" anchor="ctr">
-                    <a:solidFill>
-                      <a:srgbClr val="FFFFFF"/>
-                    </a:solidFill>
                     <a:lnL w="0">
                       <a:noFill/>
                     </a:lnL>
@@ -12947,6 +12944,9 @@
                         <a:srgbClr val="D9D3E3"/>
                       </a:solidFill>
                     </a:lnB>
+                    <a:solidFill>
+                      <a:srgbClr val="FFFFFF"/>
+                    </a:solidFill>
                   </a:tcPr>
                 </a:tc>
                 <a:tc>
@@ -12966,9 +12966,6 @@
                     </a:p>
                   </a:txBody>
                   <a:tcPr marL="54864" marR="54864" marT="18288" marB="18288" anchor="ctr">
-                    <a:solidFill>
-                      <a:srgbClr val="FFFFFF"/>
-                    </a:solidFill>
                     <a:lnL w="0">
                       <a:noFill/>
                     </a:lnL>
@@ -12983,6 +12980,9 @@
                         <a:srgbClr val="D9D3E3"/>
                       </a:solidFill>
                     </a:lnB>
+                    <a:solidFill>
+                      <a:srgbClr val="FFFFFF"/>
+                    </a:solidFill>
                   </a:tcPr>
                 </a:tc>
               </a:tr>
@@ -13004,9 +13004,6 @@
                     </a:p>
                   </a:txBody>
                   <a:tcPr marL="54864" marR="54864" marT="18288" marB="18288" anchor="ctr">
-                    <a:solidFill>
-                      <a:srgbClr val="E3DFE9"/>
-                    </a:solidFill>
                     <a:lnL w="0">
                       <a:noFill/>
                     </a:lnL>
@@ -13021,6 +13018,9 @@
                         <a:srgbClr val="D9D3E3"/>
                       </a:solidFill>
                     </a:lnB>
+                    <a:solidFill>
+                      <a:srgbClr val="E3DFE9"/>
+                    </a:solidFill>
                   </a:tcPr>
                 </a:tc>
                 <a:tc>
@@ -13040,9 +13040,6 @@
                     </a:p>
                   </a:txBody>
                   <a:tcPr marL="54864" marR="54864" marT="18288" marB="18288" anchor="ctr">
-                    <a:solidFill>
-                      <a:srgbClr val="E3DFE9"/>
-                    </a:solidFill>
                     <a:lnL w="0">
                       <a:noFill/>
                     </a:lnL>
@@ -13057,6 +13054,9 @@
                         <a:srgbClr val="D9D3E3"/>
                       </a:solidFill>
                     </a:lnB>
+                    <a:solidFill>
+                      <a:srgbClr val="E3DFE9"/>
+                    </a:solidFill>
                   </a:tcPr>
                 </a:tc>
                 <a:tc>
@@ -13076,9 +13076,6 @@
                     </a:p>
                   </a:txBody>
                   <a:tcPr marL="54864" marR="54864" marT="18288" marB="18288" anchor="ctr">
-                    <a:solidFill>
-                      <a:srgbClr val="E3DFE9"/>
-                    </a:solidFill>
                     <a:lnL w="0">
                       <a:noFill/>
                     </a:lnL>
@@ -13093,6 +13090,9 @@
                         <a:srgbClr val="D9D3E3"/>
                       </a:solidFill>
                     </a:lnB>
+                    <a:solidFill>
+                      <a:srgbClr val="E3DFE9"/>
+                    </a:solidFill>
                   </a:tcPr>
                 </a:tc>
                 <a:tc>
@@ -13112,9 +13112,6 @@
                     </a:p>
                   </a:txBody>
                   <a:tcPr marL="54864" marR="54864" marT="18288" marB="18288" anchor="ctr">
-                    <a:solidFill>
-                      <a:srgbClr val="E3DFE9"/>
-                    </a:solidFill>
                     <a:lnL w="0">
                       <a:noFill/>
                     </a:lnL>
@@ -13129,6 +13126,9 @@
                         <a:srgbClr val="D9D3E3"/>
                       </a:solidFill>
                     </a:lnB>
+                    <a:solidFill>
+                      <a:srgbClr val="E3DFE9"/>
+                    </a:solidFill>
                   </a:tcPr>
                 </a:tc>
                 <a:tc>
@@ -13148,9 +13148,6 @@
                     </a:p>
                   </a:txBody>
                   <a:tcPr marL="54864" marR="54864" marT="18288" marB="18288" anchor="ctr">
-                    <a:solidFill>
-                      <a:srgbClr val="E3DFE9"/>
-                    </a:solidFill>
                     <a:lnL w="0">
                       <a:noFill/>
                     </a:lnL>
@@ -13165,6 +13162,9 @@
                         <a:srgbClr val="D9D3E3"/>
                       </a:solidFill>
                     </a:lnB>
+                    <a:solidFill>
+                      <a:srgbClr val="E3DFE9"/>
+                    </a:solidFill>
                   </a:tcPr>
                 </a:tc>
                 <a:tc>
@@ -13184,9 +13184,6 @@
                     </a:p>
                   </a:txBody>
                   <a:tcPr marL="54864" marR="54864" marT="18288" marB="18288" anchor="ctr">
-                    <a:solidFill>
-                      <a:srgbClr val="E3DFE9"/>
-                    </a:solidFill>
                     <a:lnL w="0">
                       <a:noFill/>
                     </a:lnL>
@@ -13201,6 +13198,9 @@
                         <a:srgbClr val="D9D3E3"/>
                       </a:solidFill>
                     </a:lnB>
+                    <a:solidFill>
+                      <a:srgbClr val="E3DFE9"/>
+                    </a:solidFill>
                   </a:tcPr>
                 </a:tc>
                 <a:tc>
@@ -13220,9 +13220,6 @@
                     </a:p>
                   </a:txBody>
                   <a:tcPr marL="54864" marR="54864" marT="18288" marB="18288" anchor="ctr">
-                    <a:solidFill>
-                      <a:srgbClr val="E3DFE9"/>
-                    </a:solidFill>
                     <a:lnL w="0">
                       <a:noFill/>
                     </a:lnL>
@@ -13237,6 +13234,9 @@
                         <a:srgbClr val="D9D3E3"/>
                       </a:solidFill>
                     </a:lnB>
+                    <a:solidFill>
+                      <a:srgbClr val="E3DFE9"/>
+                    </a:solidFill>
                   </a:tcPr>
                 </a:tc>
               </a:tr>
@@ -13438,9 +13438,6 @@
                     </a:p>
                   </a:txBody>
                   <a:tcPr marL="54864" marR="54864" marT="18288" marB="18288" anchor="ctr">
-                    <a:solidFill>
-                      <a:srgbClr val="57068C"/>
-                    </a:solidFill>
                     <a:lnL w="0">
                       <a:noFill/>
                     </a:lnL>
@@ -13455,6 +13452,9 @@
                         <a:srgbClr val="D9D3E3"/>
                       </a:solidFill>
                     </a:lnB>
+                    <a:solidFill>
+                      <a:srgbClr val="57068C"/>
+                    </a:solidFill>
                   </a:tcPr>
                 </a:tc>
                 <a:tc>
@@ -13474,9 +13474,6 @@
                     </a:p>
                   </a:txBody>
                   <a:tcPr marL="54864" marR="54864" marT="18288" marB="18288" anchor="ctr">
-                    <a:solidFill>
-                      <a:srgbClr val="57068C"/>
-                    </a:solidFill>
                     <a:lnL w="0">
                       <a:noFill/>
                     </a:lnL>
@@ -13491,6 +13488,9 @@
                         <a:srgbClr val="D9D3E3"/>
                       </a:solidFill>
                     </a:lnB>
+                    <a:solidFill>
+                      <a:srgbClr val="57068C"/>
+                    </a:solidFill>
                   </a:tcPr>
                 </a:tc>
                 <a:tc>
@@ -13510,9 +13510,6 @@
                     </a:p>
                   </a:txBody>
                   <a:tcPr marL="54864" marR="54864" marT="18288" marB="18288" anchor="ctr">
-                    <a:solidFill>
-                      <a:srgbClr val="57068C"/>
-                    </a:solidFill>
                     <a:lnL w="0">
                       <a:noFill/>
                     </a:lnL>
@@ -13527,6 +13524,9 @@
                         <a:srgbClr val="D9D3E3"/>
                       </a:solidFill>
                     </a:lnB>
+                    <a:solidFill>
+                      <a:srgbClr val="57068C"/>
+                    </a:solidFill>
                   </a:tcPr>
                 </a:tc>
               </a:tr>
@@ -13548,9 +13548,6 @@
                     </a:p>
                   </a:txBody>
                   <a:tcPr marL="54864" marR="54864" marT="18288" marB="18288" anchor="ctr">
-                    <a:solidFill>
-                      <a:srgbClr val="FFFFFF"/>
-                    </a:solidFill>
                     <a:lnL w="0">
                       <a:noFill/>
                     </a:lnL>
@@ -13565,6 +13562,9 @@
                         <a:srgbClr val="D9D3E3"/>
                       </a:solidFill>
                     </a:lnB>
+                    <a:solidFill>
+                      <a:srgbClr val="FFFFFF"/>
+                    </a:solidFill>
                   </a:tcPr>
                 </a:tc>
                 <a:tc>
@@ -13584,9 +13584,6 @@
                     </a:p>
                   </a:txBody>
                   <a:tcPr marL="54864" marR="54864" marT="18288" marB="18288" anchor="ctr">
-                    <a:solidFill>
-                      <a:srgbClr val="FFFFFF"/>
-                    </a:solidFill>
                     <a:lnL w="0">
                       <a:noFill/>
                     </a:lnL>
@@ -13601,6 +13598,9 @@
                         <a:srgbClr val="D9D3E3"/>
                       </a:solidFill>
                     </a:lnB>
+                    <a:solidFill>
+                      <a:srgbClr val="FFFFFF"/>
+                    </a:solidFill>
                   </a:tcPr>
                 </a:tc>
                 <a:tc>
@@ -13620,9 +13620,6 @@
                     </a:p>
                   </a:txBody>
                   <a:tcPr marL="54864" marR="54864" marT="18288" marB="18288" anchor="ctr">
-                    <a:solidFill>
-                      <a:srgbClr val="FFFFFF"/>
-                    </a:solidFill>
                     <a:lnL w="0">
                       <a:noFill/>
                     </a:lnL>
@@ -13637,6 +13634,9 @@
                         <a:srgbClr val="D9D3E3"/>
                       </a:solidFill>
                     </a:lnB>
+                    <a:solidFill>
+                      <a:srgbClr val="FFFFFF"/>
+                    </a:solidFill>
                   </a:tcPr>
                 </a:tc>
               </a:tr>
@@ -13658,9 +13658,6 @@
                     </a:p>
                   </a:txBody>
                   <a:tcPr marL="54864" marR="54864" marT="18288" marB="18288" anchor="ctr">
-                    <a:solidFill>
-                      <a:srgbClr val="FFFFFF"/>
-                    </a:solidFill>
                     <a:lnL w="0">
                       <a:noFill/>
                     </a:lnL>
@@ -13675,6 +13672,9 @@
                         <a:srgbClr val="D9D3E3"/>
                       </a:solidFill>
                     </a:lnB>
+                    <a:solidFill>
+                      <a:srgbClr val="FFFFFF"/>
+                    </a:solidFill>
                   </a:tcPr>
                 </a:tc>
                 <a:tc>
@@ -13694,9 +13694,6 @@
                     </a:p>
                   </a:txBody>
                   <a:tcPr marL="54864" marR="54864" marT="18288" marB="18288" anchor="ctr">
-                    <a:solidFill>
-                      <a:srgbClr val="FFFFFF"/>
-                    </a:solidFill>
                     <a:lnL w="0">
                       <a:noFill/>
                     </a:lnL>
@@ -13711,6 +13708,9 @@
                         <a:srgbClr val="D9D3E3"/>
                       </a:solidFill>
                     </a:lnB>
+                    <a:solidFill>
+                      <a:srgbClr val="FFFFFF"/>
+                    </a:solidFill>
                   </a:tcPr>
                 </a:tc>
                 <a:tc>
@@ -13730,9 +13730,6 @@
                     </a:p>
                   </a:txBody>
                   <a:tcPr marL="54864" marR="54864" marT="18288" marB="18288" anchor="ctr">
-                    <a:solidFill>
-                      <a:srgbClr val="FFFFFF"/>
-                    </a:solidFill>
                     <a:lnL w="0">
                       <a:noFill/>
                     </a:lnL>
@@ -13747,6 +13744,9 @@
                         <a:srgbClr val="D9D3E3"/>
                       </a:solidFill>
                     </a:lnB>
+                    <a:solidFill>
+                      <a:srgbClr val="FFFFFF"/>
+                    </a:solidFill>
                   </a:tcPr>
                 </a:tc>
               </a:tr>
@@ -13768,9 +13768,6 @@
                     </a:p>
                   </a:txBody>
                   <a:tcPr marL="54864" marR="54864" marT="18288" marB="18288" anchor="ctr">
-                    <a:solidFill>
-                      <a:srgbClr val="FFFFFF"/>
-                    </a:solidFill>
                     <a:lnL w="0">
                       <a:noFill/>
                     </a:lnL>
@@ -13785,6 +13782,9 @@
                         <a:srgbClr val="D9D3E3"/>
                       </a:solidFill>
                     </a:lnB>
+                    <a:solidFill>
+                      <a:srgbClr val="FFFFFF"/>
+                    </a:solidFill>
                   </a:tcPr>
                 </a:tc>
                 <a:tc>
@@ -13804,9 +13804,6 @@
                     </a:p>
                   </a:txBody>
                   <a:tcPr marL="54864" marR="54864" marT="18288" marB="18288" anchor="ctr">
-                    <a:solidFill>
-                      <a:srgbClr val="FFFFFF"/>
-                    </a:solidFill>
                     <a:lnL w="0">
                       <a:noFill/>
                     </a:lnL>
@@ -13821,6 +13818,9 @@
                         <a:srgbClr val="D9D3E3"/>
                       </a:solidFill>
                     </a:lnB>
+                    <a:solidFill>
+                      <a:srgbClr val="FFFFFF"/>
+                    </a:solidFill>
                   </a:tcPr>
                 </a:tc>
                 <a:tc>
@@ -13840,9 +13840,6 @@
                     </a:p>
                   </a:txBody>
                   <a:tcPr marL="54864" marR="54864" marT="18288" marB="18288" anchor="ctr">
-                    <a:solidFill>
-                      <a:srgbClr val="FFFFFF"/>
-                    </a:solidFill>
                     <a:lnL w="0">
                       <a:noFill/>
                     </a:lnL>
@@ -13857,6 +13854,9 @@
                         <a:srgbClr val="D9D3E3"/>
                       </a:solidFill>
                     </a:lnB>
+                    <a:solidFill>
+                      <a:srgbClr val="FFFFFF"/>
+                    </a:solidFill>
                   </a:tcPr>
                 </a:tc>
               </a:tr>
@@ -13878,9 +13878,6 @@
                     </a:p>
                   </a:txBody>
                   <a:tcPr marL="54864" marR="54864" marT="18288" marB="18288" anchor="ctr">
-                    <a:solidFill>
-                      <a:srgbClr val="FFFFFF"/>
-                    </a:solidFill>
                     <a:lnL w="0">
                       <a:noFill/>
                     </a:lnL>
@@ -13895,6 +13892,9 @@
                         <a:srgbClr val="D9D3E3"/>
                       </a:solidFill>
                     </a:lnB>
+                    <a:solidFill>
+                      <a:srgbClr val="FFFFFF"/>
+                    </a:solidFill>
                   </a:tcPr>
                 </a:tc>
                 <a:tc>
@@ -13914,9 +13914,6 @@
                     </a:p>
                   </a:txBody>
                   <a:tcPr marL="54864" marR="54864" marT="18288" marB="18288" anchor="ctr">
-                    <a:solidFill>
-                      <a:srgbClr val="FFFFFF"/>
-                    </a:solidFill>
                     <a:lnL w="0">
                       <a:noFill/>
                     </a:lnL>
@@ -13931,6 +13928,9 @@
                         <a:srgbClr val="D9D3E3"/>
                       </a:solidFill>
                     </a:lnB>
+                    <a:solidFill>
+                      <a:srgbClr val="FFFFFF"/>
+                    </a:solidFill>
                   </a:tcPr>
                 </a:tc>
                 <a:tc>
@@ -13950,9 +13950,6 @@
                     </a:p>
                   </a:txBody>
                   <a:tcPr marL="54864" marR="54864" marT="18288" marB="18288" anchor="ctr">
-                    <a:solidFill>
-                      <a:srgbClr val="FFFFFF"/>
-                    </a:solidFill>
                     <a:lnL w="0">
                       <a:noFill/>
                     </a:lnL>
@@ -13967,6 +13964,9 @@
                         <a:srgbClr val="D9D3E3"/>
                       </a:solidFill>
                     </a:lnB>
+                    <a:solidFill>
+                      <a:srgbClr val="FFFFFF"/>
+                    </a:solidFill>
                   </a:tcPr>
                 </a:tc>
               </a:tr>
@@ -13988,9 +13988,6 @@
                     </a:p>
                   </a:txBody>
                   <a:tcPr marL="54864" marR="54864" marT="18288" marB="18288" anchor="ctr">
-                    <a:solidFill>
-                      <a:srgbClr val="FFFFFF"/>
-                    </a:solidFill>
                     <a:lnL w="0">
                       <a:noFill/>
                     </a:lnL>
@@ -14005,6 +14002,9 @@
                         <a:srgbClr val="D9D3E3"/>
                       </a:solidFill>
                     </a:lnB>
+                    <a:solidFill>
+                      <a:srgbClr val="FFFFFF"/>
+                    </a:solidFill>
                   </a:tcPr>
                 </a:tc>
                 <a:tc>
@@ -14024,9 +14024,6 @@
                     </a:p>
                   </a:txBody>
                   <a:tcPr marL="54864" marR="54864" marT="18288" marB="18288" anchor="ctr">
-                    <a:solidFill>
-                      <a:srgbClr val="FFFFFF"/>
-                    </a:solidFill>
                     <a:lnL w="0">
                       <a:noFill/>
                     </a:lnL>
@@ -14041,6 +14038,9 @@
                         <a:srgbClr val="D9D3E3"/>
                       </a:solidFill>
                     </a:lnB>
+                    <a:solidFill>
+                      <a:srgbClr val="FFFFFF"/>
+                    </a:solidFill>
                   </a:tcPr>
                 </a:tc>
                 <a:tc>
@@ -14060,9 +14060,6 @@
                     </a:p>
                   </a:txBody>
                   <a:tcPr marL="54864" marR="54864" marT="18288" marB="18288" anchor="ctr">
-                    <a:solidFill>
-                      <a:srgbClr val="FFFFFF"/>
-                    </a:solidFill>
                     <a:lnL w="0">
                       <a:noFill/>
                     </a:lnL>
@@ -14077,6 +14074,9 @@
                         <a:srgbClr val="D9D3E3"/>
                       </a:solidFill>
                     </a:lnB>
+                    <a:solidFill>
+                      <a:srgbClr val="FFFFFF"/>
+                    </a:solidFill>
                   </a:tcPr>
                 </a:tc>
               </a:tr>
@@ -17938,8 +17938,8 @@
         </p:nvCxnSpPr>
         <p:spPr>
           <a:xfrm>
-            <a:off x="1737360.0" y="1668780"/>
-            <a:ext cx="388620.0" cy="0"/>
+            <a:off x="1737360" y="1668780"/>
+            <a:ext cx="388620" cy="0"/>
           </a:xfrm>
           <a:prstGeom prst="line">
             <a:avLst/>
@@ -17974,8 +17974,8 @@
         </p:nvCxnSpPr>
         <p:spPr>
           <a:xfrm>
-            <a:off x="3497580.0" y="1668780"/>
-            <a:ext cx="388620.0" cy="0"/>
+            <a:off x="3497580" y="1668780"/>
+            <a:ext cx="388620" cy="0"/>
           </a:xfrm>
           <a:prstGeom prst="line">
             <a:avLst/>
@@ -18010,8 +18010,8 @@
         </p:nvCxnSpPr>
         <p:spPr>
           <a:xfrm>
-            <a:off x="5257800.0" y="1668780"/>
-            <a:ext cx="388620.0" cy="0"/>
+            <a:off x="5257800" y="1668780"/>
+            <a:ext cx="388620" cy="0"/>
           </a:xfrm>
           <a:prstGeom prst="line">
             <a:avLst/>
@@ -18046,8 +18046,8 @@
         </p:nvCxnSpPr>
         <p:spPr>
           <a:xfrm>
-            <a:off x="7018020.0" y="1668780"/>
-            <a:ext cx="388620.0" cy="0"/>
+            <a:off x="7018020" y="1668780"/>
+            <a:ext cx="388620" cy="0"/>
           </a:xfrm>
           <a:prstGeom prst="line">
             <a:avLst/>
@@ -18147,8 +18147,8 @@
         </p:nvCxnSpPr>
         <p:spPr>
           <a:xfrm>
-            <a:off x="8092440.0" y="2103120"/>
-            <a:ext cx="0.0" cy="502920"/>
+            <a:off x="8092440" y="2103120"/>
+            <a:ext cx="0" cy="502920"/>
           </a:xfrm>
           <a:prstGeom prst="line">
             <a:avLst/>
@@ -18183,8 +18183,8 @@
         </p:nvCxnSpPr>
         <p:spPr>
           <a:xfrm>
-            <a:off x="1051560.0" y="2103120"/>
-            <a:ext cx="0.0" cy="786384"/>
+            <a:off x="1051560" y="2103120"/>
+            <a:ext cx="0" cy="786384"/>
           </a:xfrm>
           <a:prstGeom prst="line">
             <a:avLst/>
@@ -18218,8 +18218,8 @@
         </p:nvCxnSpPr>
         <p:spPr>
           <a:xfrm>
-            <a:off x="1051560.0" y="2889504"/>
-            <a:ext cx="1074420.0" cy="0"/>
+            <a:off x="1051560" y="2889504"/>
+            <a:ext cx="1074420" cy="0"/>
           </a:xfrm>
           <a:prstGeom prst="line">
             <a:avLst/>
@@ -18897,9 +18897,6 @@
                     </a:p>
                   </a:txBody>
                   <a:tcPr marL="54864" marR="54864" marT="18288" marB="18288" anchor="ctr">
-                    <a:solidFill>
-                      <a:srgbClr val="57068C"/>
-                    </a:solidFill>
                     <a:lnL w="0">
                       <a:noFill/>
                     </a:lnL>
@@ -18914,6 +18911,9 @@
                         <a:srgbClr val="D9D3E3"/>
                       </a:solidFill>
                     </a:lnB>
+                    <a:solidFill>
+                      <a:srgbClr val="57068C"/>
+                    </a:solidFill>
                   </a:tcPr>
                 </a:tc>
                 <a:tc>
@@ -18933,9 +18933,6 @@
                     </a:p>
                   </a:txBody>
                   <a:tcPr marL="54864" marR="54864" marT="18288" marB="18288" anchor="ctr">
-                    <a:solidFill>
-                      <a:srgbClr val="57068C"/>
-                    </a:solidFill>
                     <a:lnL w="0">
                       <a:noFill/>
                     </a:lnL>
@@ -18950,6 +18947,9 @@
                         <a:srgbClr val="D9D3E3"/>
                       </a:solidFill>
                     </a:lnB>
+                    <a:solidFill>
+                      <a:srgbClr val="57068C"/>
+                    </a:solidFill>
                   </a:tcPr>
                 </a:tc>
                 <a:tc>
@@ -18969,9 +18969,6 @@
                     </a:p>
                   </a:txBody>
                   <a:tcPr marL="54864" marR="54864" marT="18288" marB="18288" anchor="ctr">
-                    <a:solidFill>
-                      <a:srgbClr val="57068C"/>
-                    </a:solidFill>
                     <a:lnL w="0">
                       <a:noFill/>
                     </a:lnL>
@@ -18986,6 +18983,9 @@
                         <a:srgbClr val="D9D3E3"/>
                       </a:solidFill>
                     </a:lnB>
+                    <a:solidFill>
+                      <a:srgbClr val="57068C"/>
+                    </a:solidFill>
                   </a:tcPr>
                 </a:tc>
               </a:tr>
@@ -19007,9 +19007,6 @@
                     </a:p>
                   </a:txBody>
                   <a:tcPr marL="54864" marR="54864" marT="18288" marB="18288" anchor="ctr">
-                    <a:solidFill>
-                      <a:srgbClr val="FFFFFF"/>
-                    </a:solidFill>
                     <a:lnL w="0">
                       <a:noFill/>
                     </a:lnL>
@@ -19024,6 +19021,9 @@
                         <a:srgbClr val="D9D3E3"/>
                       </a:solidFill>
                     </a:lnB>
+                    <a:solidFill>
+                      <a:srgbClr val="FFFFFF"/>
+                    </a:solidFill>
                   </a:tcPr>
                 </a:tc>
                 <a:tc>
@@ -19043,9 +19043,6 @@
                     </a:p>
                   </a:txBody>
                   <a:tcPr marL="54864" marR="54864" marT="18288" marB="18288" anchor="ctr">
-                    <a:solidFill>
-                      <a:srgbClr val="FFFFFF"/>
-                    </a:solidFill>
                     <a:lnL w="0">
                       <a:noFill/>
                     </a:lnL>
@@ -19060,6 +19057,9 @@
                         <a:srgbClr val="D9D3E3"/>
                       </a:solidFill>
                     </a:lnB>
+                    <a:solidFill>
+                      <a:srgbClr val="FFFFFF"/>
+                    </a:solidFill>
                   </a:tcPr>
                 </a:tc>
                 <a:tc>
@@ -19079,9 +19079,6 @@
                     </a:p>
                   </a:txBody>
                   <a:tcPr marL="54864" marR="54864" marT="18288" marB="18288" anchor="ctr">
-                    <a:solidFill>
-                      <a:srgbClr val="FFFFFF"/>
-                    </a:solidFill>
                     <a:lnL w="0">
                       <a:noFill/>
                     </a:lnL>
@@ -19096,6 +19093,9 @@
                         <a:srgbClr val="D9D3E3"/>
                       </a:solidFill>
                     </a:lnB>
+                    <a:solidFill>
+                      <a:srgbClr val="FFFFFF"/>
+                    </a:solidFill>
                   </a:tcPr>
                 </a:tc>
               </a:tr>
@@ -19117,9 +19117,6 @@
                     </a:p>
                   </a:txBody>
                   <a:tcPr marL="54864" marR="54864" marT="18288" marB="18288" anchor="ctr">
-                    <a:solidFill>
-                      <a:srgbClr val="FFFFFF"/>
-                    </a:solidFill>
                     <a:lnL w="0">
                       <a:noFill/>
                     </a:lnL>
@@ -19134,6 +19131,9 @@
                         <a:srgbClr val="D9D3E3"/>
                       </a:solidFill>
                     </a:lnB>
+                    <a:solidFill>
+                      <a:srgbClr val="FFFFFF"/>
+                    </a:solidFill>
                   </a:tcPr>
                 </a:tc>
                 <a:tc>
@@ -19153,9 +19153,6 @@
                     </a:p>
                   </a:txBody>
                   <a:tcPr marL="54864" marR="54864" marT="18288" marB="18288" anchor="ctr">
-                    <a:solidFill>
-                      <a:srgbClr val="FFFFFF"/>
-                    </a:solidFill>
                     <a:lnL w="0">
                       <a:noFill/>
                     </a:lnL>
@@ -19170,6 +19167,9 @@
                         <a:srgbClr val="D9D3E3"/>
                       </a:solidFill>
                     </a:lnB>
+                    <a:solidFill>
+                      <a:srgbClr val="FFFFFF"/>
+                    </a:solidFill>
                   </a:tcPr>
                 </a:tc>
                 <a:tc>
@@ -19189,9 +19189,6 @@
                     </a:p>
                   </a:txBody>
                   <a:tcPr marL="54864" marR="54864" marT="18288" marB="18288" anchor="ctr">
-                    <a:solidFill>
-                      <a:srgbClr val="FFFFFF"/>
-                    </a:solidFill>
                     <a:lnL w="0">
                       <a:noFill/>
                     </a:lnL>
@@ -19206,6 +19203,9 @@
                         <a:srgbClr val="D9D3E3"/>
                       </a:solidFill>
                     </a:lnB>
+                    <a:solidFill>
+                      <a:srgbClr val="FFFFFF"/>
+                    </a:solidFill>
                   </a:tcPr>
                 </a:tc>
               </a:tr>
@@ -19227,9 +19227,6 @@
                     </a:p>
                   </a:txBody>
                   <a:tcPr marL="54864" marR="54864" marT="18288" marB="18288" anchor="ctr">
-                    <a:solidFill>
-                      <a:srgbClr val="FFFFFF"/>
-                    </a:solidFill>
                     <a:lnL w="0">
                       <a:noFill/>
                     </a:lnL>
@@ -19244,6 +19241,9 @@
                         <a:srgbClr val="D9D3E3"/>
                       </a:solidFill>
                     </a:lnB>
+                    <a:solidFill>
+                      <a:srgbClr val="FFFFFF"/>
+                    </a:solidFill>
                   </a:tcPr>
                 </a:tc>
                 <a:tc>
@@ -19263,9 +19263,6 @@
                     </a:p>
                   </a:txBody>
                   <a:tcPr marL="54864" marR="54864" marT="18288" marB="18288" anchor="ctr">
-                    <a:solidFill>
-                      <a:srgbClr val="FFFFFF"/>
-                    </a:solidFill>
                     <a:lnL w="0">
                       <a:noFill/>
                     </a:lnL>
@@ -19280,6 +19277,9 @@
                         <a:srgbClr val="D9D3E3"/>
                       </a:solidFill>
                     </a:lnB>
+                    <a:solidFill>
+                      <a:srgbClr val="FFFFFF"/>
+                    </a:solidFill>
                   </a:tcPr>
                 </a:tc>
                 <a:tc>
@@ -19299,9 +19299,6 @@
                     </a:p>
                   </a:txBody>
                   <a:tcPr marL="54864" marR="54864" marT="18288" marB="18288" anchor="ctr">
-                    <a:solidFill>
-                      <a:srgbClr val="FFFFFF"/>
-                    </a:solidFill>
                     <a:lnL w="0">
                       <a:noFill/>
                     </a:lnL>
@@ -19316,6 +19313,9 @@
                         <a:srgbClr val="D9D3E3"/>
                       </a:solidFill>
                     </a:lnB>
+                    <a:solidFill>
+                      <a:srgbClr val="FFFFFF"/>
+                    </a:solidFill>
                   </a:tcPr>
                 </a:tc>
               </a:tr>
@@ -19337,9 +19337,6 @@
                     </a:p>
                   </a:txBody>
                   <a:tcPr marL="54864" marR="54864" marT="18288" marB="18288" anchor="ctr">
-                    <a:solidFill>
-                      <a:srgbClr val="FFFFFF"/>
-                    </a:solidFill>
                     <a:lnL w="0">
                       <a:noFill/>
                     </a:lnL>
@@ -19354,6 +19351,9 @@
                         <a:srgbClr val="D9D3E3"/>
                       </a:solidFill>
                     </a:lnB>
+                    <a:solidFill>
+                      <a:srgbClr val="FFFFFF"/>
+                    </a:solidFill>
                   </a:tcPr>
                 </a:tc>
                 <a:tc>
@@ -19373,9 +19373,6 @@
                     </a:p>
                   </a:txBody>
                   <a:tcPr marL="54864" marR="54864" marT="18288" marB="18288" anchor="ctr">
-                    <a:solidFill>
-                      <a:srgbClr val="FFFFFF"/>
-                    </a:solidFill>
                     <a:lnL w="0">
                       <a:noFill/>
                     </a:lnL>
@@ -19390,6 +19387,9 @@
                         <a:srgbClr val="D9D3E3"/>
                       </a:solidFill>
                     </a:lnB>
+                    <a:solidFill>
+                      <a:srgbClr val="FFFFFF"/>
+                    </a:solidFill>
                   </a:tcPr>
                 </a:tc>
                 <a:tc>
@@ -19409,9 +19409,6 @@
                     </a:p>
                   </a:txBody>
                   <a:tcPr marL="54864" marR="54864" marT="18288" marB="18288" anchor="ctr">
-                    <a:solidFill>
-                      <a:srgbClr val="FFFFFF"/>
-                    </a:solidFill>
                     <a:lnL w="0">
                       <a:noFill/>
                     </a:lnL>
@@ -19426,6 +19423,9 @@
                         <a:srgbClr val="D9D3E3"/>
                       </a:solidFill>
                     </a:lnB>
+                    <a:solidFill>
+                      <a:srgbClr val="FFFFFF"/>
+                    </a:solidFill>
                   </a:tcPr>
                 </a:tc>
               </a:tr>
@@ -19708,9 +19708,6 @@
                     </a:p>
                   </a:txBody>
                   <a:tcPr marL="54864" marR="54864" marT="18288" marB="18288" anchor="ctr">
-                    <a:solidFill>
-                      <a:srgbClr val="57068C"/>
-                    </a:solidFill>
                     <a:lnL w="0">
                       <a:noFill/>
                     </a:lnL>
@@ -19725,6 +19722,9 @@
                         <a:srgbClr val="D9D3E3"/>
                       </a:solidFill>
                     </a:lnB>
+                    <a:solidFill>
+                      <a:srgbClr val="57068C"/>
+                    </a:solidFill>
                   </a:tcPr>
                 </a:tc>
                 <a:tc>
@@ -19744,9 +19744,6 @@
                     </a:p>
                   </a:txBody>
                   <a:tcPr marL="54864" marR="54864" marT="18288" marB="18288" anchor="ctr">
-                    <a:solidFill>
-                      <a:srgbClr val="57068C"/>
-                    </a:solidFill>
                     <a:lnL w="0">
                       <a:noFill/>
                     </a:lnL>
@@ -19761,6 +19758,9 @@
                         <a:srgbClr val="D9D3E3"/>
                       </a:solidFill>
                     </a:lnB>
+                    <a:solidFill>
+                      <a:srgbClr val="57068C"/>
+                    </a:solidFill>
                   </a:tcPr>
                 </a:tc>
                 <a:tc>
@@ -19780,9 +19780,6 @@
                     </a:p>
                   </a:txBody>
                   <a:tcPr marL="54864" marR="54864" marT="18288" marB="18288" anchor="ctr">
-                    <a:solidFill>
-                      <a:srgbClr val="57068C"/>
-                    </a:solidFill>
                     <a:lnL w="0">
                       <a:noFill/>
                     </a:lnL>
@@ -19797,6 +19794,9 @@
                         <a:srgbClr val="D9D3E3"/>
                       </a:solidFill>
                     </a:lnB>
+                    <a:solidFill>
+                      <a:srgbClr val="57068C"/>
+                    </a:solidFill>
                   </a:tcPr>
                 </a:tc>
               </a:tr>
@@ -19818,9 +19818,6 @@
                     </a:p>
                   </a:txBody>
                   <a:tcPr marL="54864" marR="54864" marT="18288" marB="18288" anchor="ctr">
-                    <a:solidFill>
-                      <a:srgbClr val="FFFFFF"/>
-                    </a:solidFill>
                     <a:lnL w="0">
                       <a:noFill/>
                     </a:lnL>
@@ -19835,6 +19832,9 @@
                         <a:srgbClr val="D9D3E3"/>
                       </a:solidFill>
                     </a:lnB>
+                    <a:solidFill>
+                      <a:srgbClr val="FFFFFF"/>
+                    </a:solidFill>
                   </a:tcPr>
                 </a:tc>
                 <a:tc>
@@ -19854,9 +19854,6 @@
                     </a:p>
                   </a:txBody>
                   <a:tcPr marL="54864" marR="54864" marT="18288" marB="18288" anchor="ctr">
-                    <a:solidFill>
-                      <a:srgbClr val="FFFFFF"/>
-                    </a:solidFill>
                     <a:lnL w="0">
                       <a:noFill/>
                     </a:lnL>
@@ -19871,6 +19868,9 @@
                         <a:srgbClr val="D9D3E3"/>
                       </a:solidFill>
                     </a:lnB>
+                    <a:solidFill>
+                      <a:srgbClr val="FFFFFF"/>
+                    </a:solidFill>
                   </a:tcPr>
                 </a:tc>
                 <a:tc>
@@ -19890,9 +19890,6 @@
                     </a:p>
                   </a:txBody>
                   <a:tcPr marL="54864" marR="54864" marT="18288" marB="18288" anchor="ctr">
-                    <a:solidFill>
-                      <a:srgbClr val="FFFFFF"/>
-                    </a:solidFill>
                     <a:lnL w="0">
                       <a:noFill/>
                     </a:lnL>
@@ -19907,6 +19904,9 @@
                         <a:srgbClr val="D9D3E3"/>
                       </a:solidFill>
                     </a:lnB>
+                    <a:solidFill>
+                      <a:srgbClr val="FFFFFF"/>
+                    </a:solidFill>
                   </a:tcPr>
                 </a:tc>
               </a:tr>
@@ -19928,9 +19928,6 @@
                     </a:p>
                   </a:txBody>
                   <a:tcPr marL="54864" marR="54864" marT="18288" marB="18288" anchor="ctr">
-                    <a:solidFill>
-                      <a:srgbClr val="FFFFFF"/>
-                    </a:solidFill>
                     <a:lnL w="0">
                       <a:noFill/>
                     </a:lnL>
@@ -19945,6 +19942,9 @@
                         <a:srgbClr val="D9D3E3"/>
                       </a:solidFill>
                     </a:lnB>
+                    <a:solidFill>
+                      <a:srgbClr val="FFFFFF"/>
+                    </a:solidFill>
                   </a:tcPr>
                 </a:tc>
                 <a:tc>
@@ -19964,9 +19964,6 @@
                     </a:p>
                   </a:txBody>
                   <a:tcPr marL="54864" marR="54864" marT="18288" marB="18288" anchor="ctr">
-                    <a:solidFill>
-                      <a:srgbClr val="FFFFFF"/>
-                    </a:solidFill>
                     <a:lnL w="0">
                       <a:noFill/>
                     </a:lnL>
@@ -19981,6 +19978,9 @@
                         <a:srgbClr val="D9D3E3"/>
                       </a:solidFill>
                     </a:lnB>
+                    <a:solidFill>
+                      <a:srgbClr val="FFFFFF"/>
+                    </a:solidFill>
                   </a:tcPr>
                 </a:tc>
                 <a:tc>
@@ -20000,9 +20000,6 @@
                     </a:p>
                   </a:txBody>
                   <a:tcPr marL="54864" marR="54864" marT="18288" marB="18288" anchor="ctr">
-                    <a:solidFill>
-                      <a:srgbClr val="FFFFFF"/>
-                    </a:solidFill>
                     <a:lnL w="0">
                       <a:noFill/>
                     </a:lnL>
@@ -20017,6 +20014,9 @@
                         <a:srgbClr val="D9D3E3"/>
                       </a:solidFill>
                     </a:lnB>
+                    <a:solidFill>
+                      <a:srgbClr val="FFFFFF"/>
+                    </a:solidFill>
                   </a:tcPr>
                 </a:tc>
               </a:tr>
@@ -20038,9 +20038,6 @@
                     </a:p>
                   </a:txBody>
                   <a:tcPr marL="54864" marR="54864" marT="18288" marB="18288" anchor="ctr">
-                    <a:solidFill>
-                      <a:srgbClr val="FFFFFF"/>
-                    </a:solidFill>
                     <a:lnL w="0">
                       <a:noFill/>
                     </a:lnL>
@@ -20055,6 +20052,9 @@
                         <a:srgbClr val="D9D3E3"/>
                       </a:solidFill>
                     </a:lnB>
+                    <a:solidFill>
+                      <a:srgbClr val="FFFFFF"/>
+                    </a:solidFill>
                   </a:tcPr>
                 </a:tc>
                 <a:tc>
@@ -20074,9 +20074,6 @@
                     </a:p>
                   </a:txBody>
                   <a:tcPr marL="54864" marR="54864" marT="18288" marB="18288" anchor="ctr">
-                    <a:solidFill>
-                      <a:srgbClr val="FFFFFF"/>
-                    </a:solidFill>
                     <a:lnL w="0">
                       <a:noFill/>
                     </a:lnL>
@@ -20091,6 +20088,9 @@
                         <a:srgbClr val="D9D3E3"/>
                       </a:solidFill>
                     </a:lnB>
+                    <a:solidFill>
+                      <a:srgbClr val="FFFFFF"/>
+                    </a:solidFill>
                   </a:tcPr>
                 </a:tc>
                 <a:tc>
@@ -20110,9 +20110,6 @@
                     </a:p>
                   </a:txBody>
                   <a:tcPr marL="54864" marR="54864" marT="18288" marB="18288" anchor="ctr">
-                    <a:solidFill>
-                      <a:srgbClr val="FFFFFF"/>
-                    </a:solidFill>
                     <a:lnL w="0">
                       <a:noFill/>
                     </a:lnL>
@@ -20127,6 +20124,9 @@
                         <a:srgbClr val="D9D3E3"/>
                       </a:solidFill>
                     </a:lnB>
+                    <a:solidFill>
+                      <a:srgbClr val="FFFFFF"/>
+                    </a:solidFill>
                   </a:tcPr>
                 </a:tc>
               </a:tr>
@@ -20148,9 +20148,6 @@
                     </a:p>
                   </a:txBody>
                   <a:tcPr marL="54864" marR="54864" marT="18288" marB="18288" anchor="ctr">
-                    <a:solidFill>
-                      <a:srgbClr val="FFFFFF"/>
-                    </a:solidFill>
                     <a:lnL w="0">
                       <a:noFill/>
                     </a:lnL>
@@ -20165,6 +20162,9 @@
                         <a:srgbClr val="D9D3E3"/>
                       </a:solidFill>
                     </a:lnB>
+                    <a:solidFill>
+                      <a:srgbClr val="FFFFFF"/>
+                    </a:solidFill>
                   </a:tcPr>
                 </a:tc>
                 <a:tc>
@@ -20184,9 +20184,6 @@
                     </a:p>
                   </a:txBody>
                   <a:tcPr marL="54864" marR="54864" marT="18288" marB="18288" anchor="ctr">
-                    <a:solidFill>
-                      <a:srgbClr val="FFFFFF"/>
-                    </a:solidFill>
                     <a:lnL w="0">
                       <a:noFill/>
                     </a:lnL>
@@ -20201,6 +20198,9 @@
                         <a:srgbClr val="D9D3E3"/>
                       </a:solidFill>
                     </a:lnB>
+                    <a:solidFill>
+                      <a:srgbClr val="FFFFFF"/>
+                    </a:solidFill>
                   </a:tcPr>
                 </a:tc>
                 <a:tc>
@@ -20220,9 +20220,6 @@
                     </a:p>
                   </a:txBody>
                   <a:tcPr marL="54864" marR="54864" marT="18288" marB="18288" anchor="ctr">
-                    <a:solidFill>
-                      <a:srgbClr val="FFFFFF"/>
-                    </a:solidFill>
                     <a:lnL w="0">
                       <a:noFill/>
                     </a:lnL>
@@ -20237,6 +20234,9 @@
                         <a:srgbClr val="D9D3E3"/>
                       </a:solidFill>
                     </a:lnB>
+                    <a:solidFill>
+                      <a:srgbClr val="FFFFFF"/>
+                    </a:solidFill>
                   </a:tcPr>
                 </a:tc>
               </a:tr>
@@ -20952,9 +20952,6 @@
                     </a:p>
                   </a:txBody>
                   <a:tcPr marL="54864" marR="54864" marT="18288" marB="18288" anchor="ctr">
-                    <a:solidFill>
-                      <a:srgbClr val="57068C"/>
-                    </a:solidFill>
                     <a:lnL w="0">
                       <a:noFill/>
                     </a:lnL>
@@ -20969,6 +20966,9 @@
                         <a:srgbClr val="D9D3E3"/>
                       </a:solidFill>
                     </a:lnB>
+                    <a:solidFill>
+                      <a:srgbClr val="57068C"/>
+                    </a:solidFill>
                   </a:tcPr>
                 </a:tc>
                 <a:tc>
@@ -20988,9 +20988,6 @@
                     </a:p>
                   </a:txBody>
                   <a:tcPr marL="54864" marR="54864" marT="18288" marB="18288" anchor="ctr">
-                    <a:solidFill>
-                      <a:srgbClr val="57068C"/>
-                    </a:solidFill>
                     <a:lnL w="0">
                       <a:noFill/>
                     </a:lnL>
@@ -21005,6 +21002,9 @@
                         <a:srgbClr val="D9D3E3"/>
                       </a:solidFill>
                     </a:lnB>
+                    <a:solidFill>
+                      <a:srgbClr val="57068C"/>
+                    </a:solidFill>
                   </a:tcPr>
                 </a:tc>
                 <a:tc>
@@ -21024,9 +21024,6 @@
                     </a:p>
                   </a:txBody>
                   <a:tcPr marL="54864" marR="54864" marT="18288" marB="18288" anchor="ctr">
-                    <a:solidFill>
-                      <a:srgbClr val="57068C"/>
-                    </a:solidFill>
                     <a:lnL w="0">
                       <a:noFill/>
                     </a:lnL>
@@ -21041,6 +21038,9 @@
                         <a:srgbClr val="D9D3E3"/>
                       </a:solidFill>
                     </a:lnB>
+                    <a:solidFill>
+                      <a:srgbClr val="57068C"/>
+                    </a:solidFill>
                   </a:tcPr>
                 </a:tc>
               </a:tr>
@@ -21062,9 +21062,6 @@
                     </a:p>
                   </a:txBody>
                   <a:tcPr marL="54864" marR="54864" marT="18288" marB="18288" anchor="ctr">
-                    <a:solidFill>
-                      <a:srgbClr val="FFFFFF"/>
-                    </a:solidFill>
                     <a:lnL w="0">
                       <a:noFill/>
                     </a:lnL>
@@ -21079,6 +21076,9 @@
                         <a:srgbClr val="D9D3E3"/>
                       </a:solidFill>
                     </a:lnB>
+                    <a:solidFill>
+                      <a:srgbClr val="FFFFFF"/>
+                    </a:solidFill>
                   </a:tcPr>
                 </a:tc>
                 <a:tc>
@@ -21098,9 +21098,6 @@
                     </a:p>
                   </a:txBody>
                   <a:tcPr marL="54864" marR="54864" marT="18288" marB="18288" anchor="ctr">
-                    <a:solidFill>
-                      <a:srgbClr val="FFFFFF"/>
-                    </a:solidFill>
                     <a:lnL w="0">
                       <a:noFill/>
                     </a:lnL>
@@ -21115,6 +21112,9 @@
                         <a:srgbClr val="D9D3E3"/>
                       </a:solidFill>
                     </a:lnB>
+                    <a:solidFill>
+                      <a:srgbClr val="FFFFFF"/>
+                    </a:solidFill>
                   </a:tcPr>
                 </a:tc>
                 <a:tc>
@@ -21134,9 +21134,6 @@
                     </a:p>
                   </a:txBody>
                   <a:tcPr marL="54864" marR="54864" marT="18288" marB="18288" anchor="ctr">
-                    <a:solidFill>
-                      <a:srgbClr val="FFFFFF"/>
-                    </a:solidFill>
                     <a:lnL w="0">
                       <a:noFill/>
                     </a:lnL>
@@ -21151,6 +21148,9 @@
                         <a:srgbClr val="D9D3E3"/>
                       </a:solidFill>
                     </a:lnB>
+                    <a:solidFill>
+                      <a:srgbClr val="FFFFFF"/>
+                    </a:solidFill>
                   </a:tcPr>
                 </a:tc>
               </a:tr>
@@ -21172,9 +21172,6 @@
                     </a:p>
                   </a:txBody>
                   <a:tcPr marL="54864" marR="54864" marT="18288" marB="18288" anchor="ctr">
-                    <a:solidFill>
-                      <a:srgbClr val="FFFFFF"/>
-                    </a:solidFill>
                     <a:lnL w="0">
                       <a:noFill/>
                     </a:lnL>
@@ -21189,6 +21186,9 @@
                         <a:srgbClr val="D9D3E3"/>
                       </a:solidFill>
                     </a:lnB>
+                    <a:solidFill>
+                      <a:srgbClr val="FFFFFF"/>
+                    </a:solidFill>
                   </a:tcPr>
                 </a:tc>
                 <a:tc>
@@ -21208,9 +21208,6 @@
                     </a:p>
                   </a:txBody>
                   <a:tcPr marL="54864" marR="54864" marT="18288" marB="18288" anchor="ctr">
-                    <a:solidFill>
-                      <a:srgbClr val="FFFFFF"/>
-                    </a:solidFill>
                     <a:lnL w="0">
                       <a:noFill/>
                     </a:lnL>
@@ -21225,6 +21222,9 @@
                         <a:srgbClr val="D9D3E3"/>
                       </a:solidFill>
                     </a:lnB>
+                    <a:solidFill>
+                      <a:srgbClr val="FFFFFF"/>
+                    </a:solidFill>
                   </a:tcPr>
                 </a:tc>
                 <a:tc>
@@ -21244,9 +21244,6 @@
                     </a:p>
                   </a:txBody>
                   <a:tcPr marL="54864" marR="54864" marT="18288" marB="18288" anchor="ctr">
-                    <a:solidFill>
-                      <a:srgbClr val="FFFFFF"/>
-                    </a:solidFill>
                     <a:lnL w="0">
                       <a:noFill/>
                     </a:lnL>
@@ -21261,6 +21258,9 @@
                         <a:srgbClr val="D9D3E3"/>
                       </a:solidFill>
                     </a:lnB>
+                    <a:solidFill>
+                      <a:srgbClr val="FFFFFF"/>
+                    </a:solidFill>
                   </a:tcPr>
                 </a:tc>
               </a:tr>
@@ -21282,9 +21282,6 @@
                     </a:p>
                   </a:txBody>
                   <a:tcPr marL="54864" marR="54864" marT="18288" marB="18288" anchor="ctr">
-                    <a:solidFill>
-                      <a:srgbClr val="FFFFFF"/>
-                    </a:solidFill>
                     <a:lnL w="0">
                       <a:noFill/>
                     </a:lnL>
@@ -21299,6 +21296,9 @@
                         <a:srgbClr val="D9D3E3"/>
                       </a:solidFill>
                     </a:lnB>
+                    <a:solidFill>
+                      <a:srgbClr val="FFFFFF"/>
+                    </a:solidFill>
                   </a:tcPr>
                 </a:tc>
                 <a:tc>
@@ -21318,9 +21318,6 @@
                     </a:p>
                   </a:txBody>
                   <a:tcPr marL="54864" marR="54864" marT="18288" marB="18288" anchor="ctr">
-                    <a:solidFill>
-                      <a:srgbClr val="FFFFFF"/>
-                    </a:solidFill>
                     <a:lnL w="0">
                       <a:noFill/>
                     </a:lnL>
@@ -21335,6 +21332,9 @@
                         <a:srgbClr val="D9D3E3"/>
                       </a:solidFill>
                     </a:lnB>
+                    <a:solidFill>
+                      <a:srgbClr val="FFFFFF"/>
+                    </a:solidFill>
                   </a:tcPr>
                 </a:tc>
                 <a:tc>
@@ -21354,9 +21354,6 @@
                     </a:p>
                   </a:txBody>
                   <a:tcPr marL="54864" marR="54864" marT="18288" marB="18288" anchor="ctr">
-                    <a:solidFill>
-                      <a:srgbClr val="FFFFFF"/>
-                    </a:solidFill>
                     <a:lnL w="0">
                       <a:noFill/>
                     </a:lnL>
@@ -21371,6 +21368,9 @@
                         <a:srgbClr val="D9D3E3"/>
                       </a:solidFill>
                     </a:lnB>
+                    <a:solidFill>
+                      <a:srgbClr val="FFFFFF"/>
+                    </a:solidFill>
                   </a:tcPr>
                 </a:tc>
               </a:tr>
@@ -21392,9 +21392,6 @@
                     </a:p>
                   </a:txBody>
                   <a:tcPr marL="54864" marR="54864" marT="18288" marB="18288" anchor="ctr">
-                    <a:solidFill>
-                      <a:srgbClr val="FFFFFF"/>
-                    </a:solidFill>
                     <a:lnL w="0">
                       <a:noFill/>
                     </a:lnL>
@@ -21409,6 +21406,9 @@
                         <a:srgbClr val="D9D3E3"/>
                       </a:solidFill>
                     </a:lnB>
+                    <a:solidFill>
+                      <a:srgbClr val="FFFFFF"/>
+                    </a:solidFill>
                   </a:tcPr>
                 </a:tc>
                 <a:tc>
@@ -21428,9 +21428,6 @@
                     </a:p>
                   </a:txBody>
                   <a:tcPr marL="54864" marR="54864" marT="18288" marB="18288" anchor="ctr">
-                    <a:solidFill>
-                      <a:srgbClr val="FFFFFF"/>
-                    </a:solidFill>
                     <a:lnL w="0">
                       <a:noFill/>
                     </a:lnL>
@@ -21445,6 +21442,9 @@
                         <a:srgbClr val="D9D3E3"/>
                       </a:solidFill>
                     </a:lnB>
+                    <a:solidFill>
+                      <a:srgbClr val="FFFFFF"/>
+                    </a:solidFill>
                   </a:tcPr>
                 </a:tc>
                 <a:tc>
@@ -21464,9 +21464,6 @@
                     </a:p>
                   </a:txBody>
                   <a:tcPr marL="54864" marR="54864" marT="18288" marB="18288" anchor="ctr">
-                    <a:solidFill>
-                      <a:srgbClr val="FFFFFF"/>
-                    </a:solidFill>
                     <a:lnL w="0">
                       <a:noFill/>
                     </a:lnL>
@@ -21481,6 +21478,9 @@
                         <a:srgbClr val="D9D3E3"/>
                       </a:solidFill>
                     </a:lnB>
+                    <a:solidFill>
+                      <a:srgbClr val="FFFFFF"/>
+                    </a:solidFill>
                   </a:tcPr>
                 </a:tc>
               </a:tr>
@@ -21502,9 +21502,6 @@
                     </a:p>
                   </a:txBody>
                   <a:tcPr marL="54864" marR="54864" marT="18288" marB="18288" anchor="ctr">
-                    <a:solidFill>
-                      <a:srgbClr val="E3DFE9"/>
-                    </a:solidFill>
                     <a:lnL w="0">
                       <a:noFill/>
                     </a:lnL>
@@ -21519,6 +21516,9 @@
                         <a:srgbClr val="D9D3E3"/>
                       </a:solidFill>
                     </a:lnB>
+                    <a:solidFill>
+                      <a:srgbClr val="E3DFE9"/>
+                    </a:solidFill>
                   </a:tcPr>
                 </a:tc>
                 <a:tc>
@@ -21538,9 +21538,6 @@
                     </a:p>
                   </a:txBody>
                   <a:tcPr marL="54864" marR="54864" marT="18288" marB="18288" anchor="ctr">
-                    <a:solidFill>
-                      <a:srgbClr val="E3DFE9"/>
-                    </a:solidFill>
                     <a:lnL w="0">
                       <a:noFill/>
                     </a:lnL>
@@ -21555,6 +21552,9 @@
                         <a:srgbClr val="D9D3E3"/>
                       </a:solidFill>
                     </a:lnB>
+                    <a:solidFill>
+                      <a:srgbClr val="E3DFE9"/>
+                    </a:solidFill>
                   </a:tcPr>
                 </a:tc>
                 <a:tc>
@@ -21574,9 +21574,6 @@
                     </a:p>
                   </a:txBody>
                   <a:tcPr marL="54864" marR="54864" marT="18288" marB="18288" anchor="ctr">
-                    <a:solidFill>
-                      <a:srgbClr val="E3DFE9"/>
-                    </a:solidFill>
                     <a:lnL w="0">
                       <a:noFill/>
                     </a:lnL>
@@ -21591,6 +21588,9 @@
                         <a:srgbClr val="D9D3E3"/>
                       </a:solidFill>
                     </a:lnB>
+                    <a:solidFill>
+                      <a:srgbClr val="E3DFE9"/>
+                    </a:solidFill>
                   </a:tcPr>
                 </a:tc>
               </a:tr>

</xml_diff>

<commit_message>
slides: give chart axes valid positive ids so Google Slides opens the deck
</commit_message>
<xml_diff>
--- a/slides/DEM_advisor_deck.pptx
+++ b/slides/DEM_advisor_deck.pptx
@@ -499,11 +499,11 @@
           <c:showLeaderLines val="1"/>
         </c:dLbls>
         <c:gapWidth val="60"/>
-        <c:axId val="-2068027336"/>
-        <c:axId val="-2113994440"/>
+        <c:axId val="500000001"/>
+        <c:axId val="500000002"/>
       </c:barChart>
       <c:catAx>
-        <c:axId val="-2068027336"/>
+        <c:axId val="500000001"/>
         <c:scaling>
           <c:orientation val="minMax"/>
         </c:scaling>
@@ -525,7 +525,7 @@
             </a:pPr>
           </a:p>
         </c:txPr>
-        <c:crossAx val="-2113994440"/>
+        <c:crossAx val="500000002"/>
         <c:crosses val="autoZero"/>
         <c:auto val="1"/>
         <c:lblAlgn val="ctr"/>
@@ -533,7 +533,7 @@
         <c:noMultiLvlLbl val="0"/>
       </c:catAx>
       <c:valAx>
-        <c:axId val="-2113994440"/>
+        <c:axId val="500000002"/>
         <c:scaling>
           <c:max val="35.0"/>
           <c:min val="0.0"/>
@@ -570,7 +570,7 @@
             </a:pPr>
           </a:p>
         </c:txPr>
-        <c:crossAx val="-2068027336"/>
+        <c:crossAx val="500000001"/>
         <c:crosses val="autoZero"/>
       </c:valAx>
     </c:plotArea>

</xml_diff>